<commit_message>
Validate route identity and quarantine newly scored documents
</commit_message>
<xml_diff>
--- a/docs/Alwaz-LeakShield.pptx
+++ b/docs/Alwaz-LeakShield.pptx
@@ -5819,7 +5819,7 @@
                         </a:defRPr>
                       </a:pPr>
                       <a:r>
-                        <a:t>19 passed · 0 failed</a:t>
+                        <a:t>20 passed · 0 failed</a:t>
                       </a:r>
                     </a:p>
                   </a:txBody>
@@ -5969,7 +5969,7 @@
                         </a:defRPr>
                       </a:pPr>
                       <a:r>
-                        <a:t>0.304 / 1.005 ms</a:t>
+                        <a:t>0.398 / 1.398 ms</a:t>
                       </a:r>
                     </a:p>
                   </a:txBody>

</xml_diff>

<commit_message>
Integrate real detectors, secure HTTP chat and approval UI
</commit_message>
<xml_diff>
--- a/docs/Alwaz-LeakShield.pptx
+++ b/docs/Alwaz-LeakShield.pptx
@@ -4870,7 +4870,7 @@
               </a:defRPr>
             </a:pPr>
             <a:r>
-              <a:t>The provider and final scanner callbacks are supplied by the team gateway.</a:t>
+              <a:t>Actual detector callbacks are integrated; the local provider is explicitly simulated.</a:t>
             </a:r>
           </a:p>
         </p:txBody>
@@ -5664,7 +5664,7 @@
               </a:defRPr>
             </a:pPr>
             <a:r>
-              <a:t>Real local MongoDB · simulated provider · development fixtures</a:t>
+              <a:t>HTTP, JWT, real MongoDB and detectors · simulated provider</a:t>
             </a:r>
           </a:p>
         </p:txBody>
@@ -5819,7 +5819,7 @@
                         </a:defRPr>
                       </a:pPr>
                       <a:r>
-                        <a:t>20 passed · 0 failed</a:t>
+                        <a:t>141 passed · 0 failed</a:t>
                       </a:r>
                     </a:p>
                   </a:txBody>
@@ -5945,7 +5945,7 @@
                         </a:defRPr>
                       </a:pPr>
                       <a:r>
-                        <a:t>Local access p50 / p95</a:t>
+                        <a:t>HTTP integration p50 / p95</a:t>
                       </a:r>
                     </a:p>
                   </a:txBody>
@@ -5969,7 +5969,7 @@
                         </a:defRPr>
                       </a:pPr>
                       <a:r>
-                        <a:t>0.398 / 1.398 ms</a:t>
+                        <a:t>2.405 / 4.192 ms</a:t>
                       </a:r>
                     </a:p>
                   </a:txBody>
@@ -6018,7 +6018,7 @@
               </a:defRPr>
             </a:pPr>
             <a:r>
-              <a:t>Excludes real detectors, model/network time and human approval wait. This is not the final frozen gateway evaluation.</a:t>
+              <a:t>Includes real detectors. Excludes model/network time and human approval wait. This is not the final frozen gateway evaluation.</a:t>
             </a:r>
           </a:p>
         </p:txBody>
@@ -7089,7 +7089,7 @@
               </a:defRPr>
             </a:pPr>
             <a:r>
-              <a:t>Ready: access modules, approval backend, seed, fixtures, Node classifier spike and reproducible tests.</a:t>
+              <a:t>Ready: access, encrypted approvals, HTTP/JWT, scoped vault, actual detectors and connected approval UI.</a:t>
             </a:r>
           </a:p>
         </p:txBody>
@@ -7128,7 +7128,7 @@
               </a:defRPr>
             </a:pPr>
             <a:r>
-              <a:t>Team integration: real gateway scans and vault, UI wiring, audit privacy, Groq/Ollama baseline and frozen evaluation.</a:t>
+              <a:t>Remaining: team Groq settings, actual Groq/Ollama transport, full frozen evaluation and real-model rehearsal.</a:t>
             </a:r>
           </a:p>
         </p:txBody>

</xml_diff>

<commit_message>
Add configurable provider transport and finalize integration evidence
</commit_message>
<xml_diff>
--- a/docs/Alwaz-LeakShield.pptx
+++ b/docs/Alwaz-LeakShield.pptx
@@ -5819,7 +5819,7 @@
                         </a:defRPr>
                       </a:pPr>
                       <a:r>
-                        <a:t>141 passed · 0 failed</a:t>
+                        <a:t>143 passed · 0 failed</a:t>
                       </a:r>
                     </a:p>
                   </a:txBody>
@@ -5969,7 +5969,7 @@
                         </a:defRPr>
                       </a:pPr>
                       <a:r>
-                        <a:t>2.405 / 4.192 ms</a:t>
+                        <a:t>2.344 / 4.369 ms</a:t>
                       </a:r>
                     </a:p>
                   </a:txBody>
@@ -7128,7 +7128,7 @@
               </a:defRPr>
             </a:pPr>
             <a:r>
-              <a:t>Remaining: team Groq settings, actual Groq/Ollama transport, full frozen evaluation and real-model rehearsal.</a:t>
+              <a:t>Remaining: team Groq settings, a real Groq/Ollama run, full frozen evaluation and real-model rehearsal.</a:t>
             </a:r>
           </a:p>
         </p:txBody>

</xml_diff>

<commit_message>
Align detector workspace lockfile and refresh merged validation deck
</commit_message>
<xml_diff>
--- a/docs/Alwaz-LeakShield.pptx
+++ b/docs/Alwaz-LeakShield.pptx
@@ -5664,7 +5664,7 @@
               </a:defRPr>
             </a:pPr>
             <a:r>
-              <a:t>HTTP, JWT, real MongoDB and detectors · simulated provider</a:t>
+              <a:t>Reference-host HTTP timing · merged suites use simulated providers</a:t>
             </a:r>
           </a:p>
         </p:txBody>
@@ -5819,7 +5819,7 @@
                         </a:defRPr>
                       </a:pPr>
                       <a:r>
-                        <a:t>143 passed · 0 failed</a:t>
+                        <a:t>219 + 21 passed · 0 failed</a:t>
                       </a:r>
                     </a:p>
                   </a:txBody>
@@ -7089,7 +7089,7 @@
               </a:defRPr>
             </a:pPr>
             <a:r>
-              <a:t>Ready: access, encrypted approvals, HTTP/JWT, scoped vault, actual detectors and connected approval UI.</a:t>
+              <a:t>Ready: merged gateway, actual detectors, ACLs, encrypted approval replay, audit and connected UI.</a:t>
             </a:r>
           </a:p>
         </p:txBody>

</xml_diff>

<commit_message>
Update the team deck with frozen results; add limitations and narrator docs
docs/Alwaz-LeakShield.pptx (one team deck, 8 -> 10 slides):
- new slide 6 "Frozen held-out results": provider leaks 12 -> 1, exact
  action 48/60 vs 26/60, recall/precision 1.00/0.82, 7/28 allowed
  interrupted, robustness retention 0.95, overhead 24/70 ms
- new slide 7 "Detector misses and why": Hinglish 4/8, retrieval 4/28,
  detector 3/28, IFSC leak; fixes deferred to the next freeze
- slide 8 classifier: real-model check (19/110 normal flagged), off by
  default, q8 refused
- slide 10 limits: frozen evaluation done; next-freeze items; Groq
  retention left to the account owner
Validated with the pptx validator against the original deck.

docs/LIMITATIONS.md: five limits with evidence (TEAM.md hour 17-19 task).
docs/NARRATOR.md: narrator cheat-sheet with the frozen numbers and the
three answers from the review (1 leak, 7/28, Hinglish).

Co-Authored-By: Claude Opus 5.5 <noreply@anthropic.com>
</commit_message>
<xml_diff>
--- a/docs/Alwaz-LeakShield.pptx
+++ b/docs/Alwaz-LeakShield.pptx
@@ -10,6 +10,8 @@
     <p:sldId id="258" r:id="rId10"/>
     <p:sldId id="259" r:id="rId11"/>
     <p:sldId id="260" r:id="rId12"/>
+    <p:sldId id="264" r:id="rId16"/>
+    <p:sldId id="265" r:id="rId17"/>
     <p:sldId id="261" r:id="rId13"/>
     <p:sldId id="262" r:id="rId14"/>
     <p:sldId id="263" r:id="rId15"/>
@@ -4022,6 +4024,675 @@
 </p:sld>
 </file>
 
+<file path=ppt/slides/slide10.xml><?xml version="1.0" encoding="utf-8"?>
+<p:sld xmlns:a="http://schemas.openxmlformats.org/drawingml/2006/main" xmlns:p="http://schemas.openxmlformats.org/presentationml/2006/main" xmlns:r="http://schemas.openxmlformats.org/officeDocument/2006/relationships">
+  <p:cSld>
+    <p:bg>
+      <p:bgPr>
+        <a:solidFill>
+          <a:srgbClr val="111B2B"/>
+        </a:solidFill>
+        <a:effectLst/>
+      </p:bgPr>
+    </p:bg>
+    <p:spTree>
+      <p:nvGrpSpPr>
+        <p:cNvPr id="1" name=""/>
+        <p:cNvGrpSpPr/>
+        <p:nvPr/>
+      </p:nvGrpSpPr>
+      <p:grpSpPr/>
+      <p:sp>
+        <p:nvSpPr>
+          <p:cNvPr id="2" name="TextBox 1"/>
+          <p:cNvSpPr txBox="1"/>
+          <p:nvPr/>
+        </p:nvSpPr>
+        <p:spPr>
+          <a:xfrm>
+            <a:off x="594360" y="438912"/>
+            <a:ext cx="10972800" cy="914400"/>
+          </a:xfrm>
+          <a:prstGeom prst="rect">
+            <a:avLst/>
+          </a:prstGeom>
+          <a:noFill/>
+        </p:spPr>
+        <p:txBody>
+          <a:bodyPr wrap="square">
+            <a:spAutoFit/>
+          </a:bodyPr>
+          <a:lstStyle/>
+          <a:p>
+            <a:pPr>
+              <a:spcAft>
+                <a:spcPts val="1400"/>
+              </a:spcAft>
+              <a:defRPr sz="3600" b="1">
+                <a:solidFill>
+                  <a:srgbClr val="F1F5FA"/>
+                </a:solidFill>
+                <a:latin typeface="Aptos"/>
+              </a:defRPr>
+            </a:pPr>
+            <a:r>
+              <a:t>Detector misses and why</a:t>
+            </a:r>
+          </a:p>
+        </p:txBody>
+      </p:sp>
+      <p:sp>
+        <p:nvSpPr>
+          <p:cNvPr id="3" name="TextBox 2"/>
+          <p:cNvSpPr txBox="1"/>
+          <p:nvPr/>
+        </p:nvSpPr>
+        <p:spPr>
+          <a:xfrm>
+            <a:off x="621792" y="1371600"/>
+            <a:ext cx="10972800" cy="640080"/>
+          </a:xfrm>
+          <a:prstGeom prst="rect">
+            <a:avLst/>
+          </a:prstGeom>
+          <a:noFill/>
+        </p:spPr>
+        <p:txBody>
+          <a:bodyPr wrap="square">
+            <a:spAutoFit/>
+          </a:bodyPr>
+          <a:lstStyle/>
+          <a:p>
+            <a:pPr>
+              <a:spcAft>
+                <a:spcPts val="1400"/>
+              </a:spcAft>
+              <a:defRPr sz="1900" b="0">
+                <a:solidFill>
+                  <a:srgbClr val="B6C3D7"/>
+                </a:solidFill>
+                <a:latin typeface="Aptos"/>
+              </a:defRPr>
+            </a:pPr>
+            <a:r>
+              <a:t>Analysed after the freeze, not tuned · rules caught 32 of 36 injections and 37 of 37 data categories</a:t>
+            </a:r>
+          </a:p>
+        </p:txBody>
+      </p:sp>
+      <p:sp>
+        <p:nvSpPr>
+          <p:cNvPr id="4" name="TextBox 3"/>
+          <p:cNvSpPr txBox="1"/>
+          <p:nvPr/>
+        </p:nvSpPr>
+        <p:spPr>
+          <a:xfrm>
+            <a:off x="11064240" y="6355080"/>
+            <a:ext cx="457200" cy="274320"/>
+          </a:xfrm>
+          <a:prstGeom prst="rect">
+            <a:avLst/>
+          </a:prstGeom>
+          <a:noFill/>
+        </p:spPr>
+        <p:txBody>
+          <a:bodyPr wrap="square">
+            <a:spAutoFit/>
+          </a:bodyPr>
+          <a:lstStyle/>
+          <a:p>
+            <a:pPr>
+              <a:spcAft>
+                <a:spcPts val="1400"/>
+              </a:spcAft>
+              <a:defRPr sz="1200" b="0">
+                <a:solidFill>
+                  <a:srgbClr val="B6C3D7"/>
+                </a:solidFill>
+                <a:latin typeface="Aptos"/>
+              </a:defRPr>
+            </a:pPr>
+            <a:r>
+              <a:t>7</a:t>
+            </a:r>
+          </a:p>
+        </p:txBody>
+      </p:sp>
+      <p:graphicFrame>
+        <p:nvGraphicFramePr>
+          <p:cNvPr id="5" name="Table 4"/>
+          <p:cNvGraphicFramePr>
+            <a:graphicFrameLocks noGrp="1"/>
+          </p:cNvGraphicFramePr>
+          <p:nvPr/>
+        </p:nvGraphicFramePr>
+        <p:xfrm>
+          <a:off x="640080" y="1828800"/>
+          <a:ext cx="10881360" cy="3291840"/>
+        </p:xfrm>
+        <a:graphic>
+          <a:graphicData uri="http://schemas.openxmlformats.org/drawingml/2006/table">
+            <a:tbl>
+              <a:tblPr firstRow="1" bandRow="1">
+                <a:tableStyleId>{5C22544A-7EE6-4342-B048-85BDC9FD1C3A}</a:tableStyleId>
+              </a:tblPr>
+              <a:tblGrid>
+                <a:gridCol w="3474720"/>
+                <a:gridCol w="1463040"/>
+                <a:gridCol w="5943600"/>
+              </a:tblGrid>
+              <a:tr h="640080">
+                <a:tc>
+                  <a:txBody>
+                    <a:bodyPr/>
+                    <a:lstStyle/>
+                    <a:p>
+                      <a:pPr>
+                        <a:defRPr sz="1600" b="1">
+                          <a:solidFill>
+                            <a:srgbClr val="64DEB1"/>
+                          </a:solidFill>
+                          <a:latin typeface="Aptos"/>
+                        </a:defRPr>
+                      </a:pPr>
+                      <a:r>
+                        <a:rPr lang="en-IN" sz="1600" b="1">
+                          <a:solidFill>
+                            <a:srgbClr val="64DEB1"/>
+                          </a:solidFill>
+                          <a:latin typeface="Aptos"/>
+                        </a:rPr>
+                        <a:t>Miss</a:t>
+                      </a:r>
+                    </a:p>
+                  </a:txBody>
+                  <a:tcPr>
+                    <a:solidFill>
+                      <a:srgbClr val="243449"/>
+                    </a:solidFill>
+                  </a:tcPr>
+                </a:tc>
+                <a:tc>
+                  <a:txBody>
+                    <a:bodyPr/>
+                    <a:lstStyle/>
+                    <a:p>
+                      <a:pPr>
+                        <a:defRPr sz="1600" b="1">
+                          <a:solidFill>
+                            <a:srgbClr val="64DEB1"/>
+                          </a:solidFill>
+                          <a:latin typeface="Aptos"/>
+                        </a:defRPr>
+                      </a:pPr>
+                      <a:r>
+                        <a:rPr lang="en-IN" sz="1600" b="1">
+                          <a:solidFill>
+                            <a:srgbClr val="64DEB1"/>
+                          </a:solidFill>
+                          <a:latin typeface="Aptos"/>
+                        </a:rPr>
+                        <a:t>Count</a:t>
+                      </a:r>
+                    </a:p>
+                  </a:txBody>
+                  <a:tcPr>
+                    <a:solidFill>
+                      <a:srgbClr val="243449"/>
+                    </a:solidFill>
+                  </a:tcPr>
+                </a:tc>
+                <a:tc>
+                  <a:txBody>
+                    <a:bodyPr/>
+                    <a:lstStyle/>
+                    <a:p>
+                      <a:pPr>
+                        <a:defRPr sz="1600" b="1">
+                          <a:solidFill>
+                            <a:srgbClr val="64DEB1"/>
+                          </a:solidFill>
+                          <a:latin typeface="Aptos"/>
+                        </a:defRPr>
+                      </a:pPr>
+                      <a:r>
+                        <a:rPr lang="en-IN" sz="1600" b="1">
+                          <a:solidFill>
+                            <a:srgbClr val="64DEB1"/>
+                          </a:solidFill>
+                          <a:latin typeface="Aptos"/>
+                        </a:rPr>
+                        <a:t>Cause</a:t>
+                      </a:r>
+                    </a:p>
+                  </a:txBody>
+                  <a:tcPr>
+                    <a:solidFill>
+                      <a:srgbClr val="243449"/>
+                    </a:solidFill>
+                  </a:tcPr>
+                </a:tc>
+              </a:tr>
+              <a:tr h="640080">
+                <a:tc>
+                  <a:txBody>
+                    <a:bodyPr/>
+                    <a:lstStyle/>
+                    <a:p>
+                      <a:pPr>
+                        <a:defRPr sz="1600" b="0">
+                          <a:solidFill>
+                            <a:srgbClr val="F1F5FA"/>
+                          </a:solidFill>
+                          <a:latin typeface="Aptos"/>
+                        </a:defRPr>
+                      </a:pPr>
+                      <a:r>
+                        <a:rPr lang="en-IN" sz="1600" b="0">
+                          <a:solidFill>
+                            <a:srgbClr val="F1F5FA"/>
+                          </a:solidFill>
+                          <a:latin typeface="Aptos"/>
+                        </a:rPr>
+                        <a:t>Hinglish rewrites missed by rules</a:t>
+                      </a:r>
+                    </a:p>
+                  </a:txBody>
+                  <a:tcPr>
+                    <a:solidFill>
+                      <a:srgbClr val="111B2B"/>
+                    </a:solidFill>
+                  </a:tcPr>
+                </a:tc>
+                <a:tc>
+                  <a:txBody>
+                    <a:bodyPr/>
+                    <a:lstStyle/>
+                    <a:p>
+                      <a:pPr>
+                        <a:defRPr sz="1600" b="0">
+                          <a:solidFill>
+                            <a:srgbClr val="F1F5FA"/>
+                          </a:solidFill>
+                          <a:latin typeface="Aptos"/>
+                        </a:defRPr>
+                      </a:pPr>
+                      <a:r>
+                        <a:rPr lang="en-IN" sz="1600" b="0">
+                          <a:solidFill>
+                            <a:srgbClr val="F1F5FA"/>
+                          </a:solidFill>
+                          <a:latin typeface="Aptos"/>
+                        </a:rPr>
+                        <a:t>4 of 8</a:t>
+                      </a:r>
+                    </a:p>
+                  </a:txBody>
+                  <a:tcPr>
+                    <a:solidFill>
+                      <a:srgbClr val="111B2B"/>
+                    </a:solidFill>
+                  </a:tcPr>
+                </a:tc>
+                <a:tc>
+                  <a:txBody>
+                    <a:bodyPr/>
+                    <a:lstStyle/>
+                    <a:p>
+                      <a:pPr>
+                        <a:defRPr sz="1600" b="0">
+                          <a:solidFill>
+                            <a:srgbClr val="F1F5FA"/>
+                          </a:solidFill>
+                          <a:latin typeface="Aptos"/>
+                        </a:defRPr>
+                      </a:pPr>
+                      <a:r>
+                        <a:rPr lang="en-IN" sz="1600" b="0">
+                          <a:solidFill>
+                            <a:srgbClr val="F1F5FA"/>
+                          </a:solidFill>
+                          <a:latin typeface="Aptos"/>
+                        </a:rPr>
+                        <a:t>Words outside the Hinglish lists; English words inside Devanagari</a:t>
+                      </a:r>
+                    </a:p>
+                  </a:txBody>
+                  <a:tcPr>
+                    <a:solidFill>
+                      <a:srgbClr val="111B2B"/>
+                    </a:solidFill>
+                  </a:tcPr>
+                </a:tc>
+              </a:tr>
+              <a:tr h="640080">
+                <a:tc>
+                  <a:txBody>
+                    <a:bodyPr/>
+                    <a:lstStyle/>
+                    <a:p>
+                      <a:pPr>
+                        <a:defRPr sz="1600" b="0">
+                          <a:solidFill>
+                            <a:srgbClr val="F1F5FA"/>
+                          </a:solidFill>
+                          <a:latin typeface="Aptos"/>
+                        </a:defRPr>
+                      </a:pPr>
+                      <a:r>
+                        <a:rPr lang="en-IN" sz="1600" b="0">
+                          <a:solidFill>
+                            <a:srgbClr val="F1F5FA"/>
+                          </a:solidFill>
+                          <a:latin typeface="Aptos"/>
+                        </a:rPr>
+                        <a:t>Allowed work interrupted: retrieval</a:t>
+                      </a:r>
+                    </a:p>
+                  </a:txBody>
+                  <a:tcPr>
+                    <a:solidFill>
+                      <a:srgbClr val="111B2B"/>
+                    </a:solidFill>
+                  </a:tcPr>
+                </a:tc>
+                <a:tc>
+                  <a:txBody>
+                    <a:bodyPr/>
+                    <a:lstStyle/>
+                    <a:p>
+                      <a:pPr>
+                        <a:defRPr sz="1600" b="0">
+                          <a:solidFill>
+                            <a:srgbClr val="F1F5FA"/>
+                          </a:solidFill>
+                          <a:latin typeface="Aptos"/>
+                        </a:defRPr>
+                      </a:pPr>
+                      <a:r>
+                        <a:rPr lang="en-IN" sz="1600" b="0">
+                          <a:solidFill>
+                            <a:srgbClr val="F1F5FA"/>
+                          </a:solidFill>
+                          <a:latin typeface="Aptos"/>
+                        </a:rPr>
+                        <a:t>4 of 28</a:t>
+                      </a:r>
+                    </a:p>
+                  </a:txBody>
+                  <a:tcPr>
+                    <a:solidFill>
+                      <a:srgbClr val="111B2B"/>
+                    </a:solidFill>
+                  </a:tcPr>
+                </a:tc>
+                <a:tc>
+                  <a:txBody>
+                    <a:bodyPr/>
+                    <a:lstStyle/>
+                    <a:p>
+                      <a:pPr>
+                        <a:defRPr sz="1600" b="0">
+                          <a:solidFill>
+                            <a:srgbClr val="F1F5FA"/>
+                          </a:solidFill>
+                          <a:latin typeface="Aptos"/>
+                        </a:defRPr>
+                      </a:pPr>
+                      <a:r>
+                        <a:rPr lang="en-IN" sz="1600" b="0">
+                          <a:solidFill>
+                            <a:srgbClr val="F1F5FA"/>
+                          </a:solidFill>
+                          <a:latin typeface="Aptos"/>
+                        </a:rPr>
+                        <a:t>An unrelated sensitive document was retrieved; relevance ranking came after this freeze</a:t>
+                      </a:r>
+                    </a:p>
+                  </a:txBody>
+                  <a:tcPr>
+                    <a:solidFill>
+                      <a:srgbClr val="111B2B"/>
+                    </a:solidFill>
+                  </a:tcPr>
+                </a:tc>
+              </a:tr>
+              <a:tr h="640080">
+                <a:tc>
+                  <a:txBody>
+                    <a:bodyPr/>
+                    <a:lstStyle/>
+                    <a:p>
+                      <a:pPr>
+                        <a:defRPr sz="1600" b="0">
+                          <a:solidFill>
+                            <a:srgbClr val="F1F5FA"/>
+                          </a:solidFill>
+                          <a:latin typeface="Aptos"/>
+                        </a:defRPr>
+                      </a:pPr>
+                      <a:r>
+                        <a:rPr lang="en-IN" sz="1600" b="0">
+                          <a:solidFill>
+                            <a:srgbClr val="F1F5FA"/>
+                          </a:solidFill>
+                          <a:latin typeface="Aptos"/>
+                        </a:rPr>
+                        <a:t>Allowed work interrupted: detector</a:t>
+                      </a:r>
+                    </a:p>
+                  </a:txBody>
+                  <a:tcPr>
+                    <a:solidFill>
+                      <a:srgbClr val="111B2B"/>
+                    </a:solidFill>
+                  </a:tcPr>
+                </a:tc>
+                <a:tc>
+                  <a:txBody>
+                    <a:bodyPr/>
+                    <a:lstStyle/>
+                    <a:p>
+                      <a:pPr>
+                        <a:defRPr sz="1600" b="0">
+                          <a:solidFill>
+                            <a:srgbClr val="F1F5FA"/>
+                          </a:solidFill>
+                          <a:latin typeface="Aptos"/>
+                        </a:defRPr>
+                      </a:pPr>
+                      <a:r>
+                        <a:rPr lang="en-IN" sz="1600" b="0">
+                          <a:solidFill>
+                            <a:srgbClr val="F1F5FA"/>
+                          </a:solidFill>
+                          <a:latin typeface="Aptos"/>
+                        </a:rPr>
+                        <a:t>3 of 28</a:t>
+                      </a:r>
+                    </a:p>
+                  </a:txBody>
+                  <a:tcPr>
+                    <a:solidFill>
+                      <a:srgbClr val="111B2B"/>
+                    </a:solidFill>
+                  </a:tcPr>
+                </a:tc>
+                <a:tc>
+                  <a:txBody>
+                    <a:bodyPr/>
+                    <a:lstStyle/>
+                    <a:p>
+                      <a:pPr>
+                        <a:defRPr sz="1600" b="0">
+                          <a:solidFill>
+                            <a:srgbClr val="F1F5FA"/>
+                          </a:solidFill>
+                          <a:latin typeface="Aptos"/>
+                        </a:defRPr>
+                      </a:pPr>
+                      <a:r>
+                        <a:rPr lang="en-IN" sz="1600" b="0">
+                          <a:solidFill>
+                            <a:srgbClr val="F1F5FA"/>
+                          </a:solidFill>
+                          <a:latin typeface="Aptos"/>
+                        </a:rPr>
+                        <a:t>A placeholder key; an answer explaining an attack; an email-like address read as UPI</a:t>
+                      </a:r>
+                    </a:p>
+                  </a:txBody>
+                  <a:tcPr>
+                    <a:solidFill>
+                      <a:srgbClr val="111B2B"/>
+                    </a:solidFill>
+                  </a:tcPr>
+                </a:tc>
+              </a:tr>
+              <a:tr h="640080">
+                <a:tc>
+                  <a:txBody>
+                    <a:bodyPr/>
+                    <a:lstStyle/>
+                    <a:p>
+                      <a:pPr>
+                        <a:defRPr sz="1600" b="0">
+                          <a:solidFill>
+                            <a:srgbClr val="F1F5FA"/>
+                          </a:solidFill>
+                          <a:latin typeface="Aptos"/>
+                        </a:defRPr>
+                      </a:pPr>
+                      <a:r>
+                        <a:rPr lang="en-IN" sz="1600" b="0">
+                          <a:solidFill>
+                            <a:srgbClr val="F1F5FA"/>
+                          </a:solidFill>
+                          <a:latin typeface="Aptos"/>
+                        </a:rPr>
+                        <a:t>Provider leak</a:t>
+                      </a:r>
+                    </a:p>
+                  </a:txBody>
+                  <a:tcPr>
+                    <a:solidFill>
+                      <a:srgbClr val="111B2B"/>
+                    </a:solidFill>
+                  </a:tcPr>
+                </a:tc>
+                <a:tc>
+                  <a:txBody>
+                    <a:bodyPr/>
+                    <a:lstStyle/>
+                    <a:p>
+                      <a:pPr>
+                        <a:defRPr sz="1600" b="0">
+                          <a:solidFill>
+                            <a:srgbClr val="F1F5FA"/>
+                          </a:solidFill>
+                          <a:latin typeface="Aptos"/>
+                        </a:defRPr>
+                      </a:pPr>
+                      <a:r>
+                        <a:rPr lang="en-IN" sz="1600" b="0">
+                          <a:solidFill>
+                            <a:srgbClr val="F1F5FA"/>
+                          </a:solidFill>
+                          <a:latin typeface="Aptos"/>
+                        </a:rPr>
+                        <a:t>1 of 60</a:t>
+                      </a:r>
+                    </a:p>
+                  </a:txBody>
+                  <a:tcPr>
+                    <a:solidFill>
+                      <a:srgbClr val="111B2B"/>
+                    </a:solidFill>
+                  </a:tcPr>
+                </a:tc>
+                <a:tc>
+                  <a:txBody>
+                    <a:bodyPr/>
+                    <a:lstStyle/>
+                    <a:p>
+                      <a:pPr>
+                        <a:defRPr sz="1600" b="0">
+                          <a:solidFill>
+                            <a:srgbClr val="F1F5FA"/>
+                          </a:solidFill>
+                          <a:latin typeface="Aptos"/>
+                        </a:defRPr>
+                      </a:pPr>
+                      <a:r>
+                        <a:rPr lang="en-IN" sz="1600" b="0">
+                          <a:solidFill>
+                            <a:srgbClr val="F1F5FA"/>
+                          </a:solidFill>
+                          <a:latin typeface="Aptos"/>
+                        </a:rPr>
+                        <a:t>IFSC code: policy warns instead of masking</a:t>
+                      </a:r>
+                    </a:p>
+                  </a:txBody>
+                  <a:tcPr>
+                    <a:solidFill>
+                      <a:srgbClr val="111B2B"/>
+                    </a:solidFill>
+                  </a:tcPr>
+                </a:tc>
+              </a:tr>
+            </a:tbl>
+          </a:graphicData>
+        </a:graphic>
+      </p:graphicFrame>
+      <p:sp>
+        <p:nvSpPr>
+          <p:cNvPr id="6" name="TextBox 5"/>
+          <p:cNvSpPr txBox="1"/>
+          <p:nvPr/>
+        </p:nvSpPr>
+        <p:spPr>
+          <a:xfrm>
+            <a:off x="685800" y="5486400"/>
+            <a:ext cx="10698480" cy="822960"/>
+          </a:xfrm>
+          <a:prstGeom prst="rect">
+            <a:avLst/>
+          </a:prstGeom>
+          <a:noFill/>
+        </p:spPr>
+        <p:txBody>
+          <a:bodyPr wrap="square">
+            <a:spAutoFit/>
+          </a:bodyPr>
+          <a:lstStyle/>
+          <a:p>
+            <a:pPr>
+              <a:spcAft>
+                <a:spcPts val="1400"/>
+              </a:spcAft>
+              <a:defRPr sz="1600" b="0">
+                <a:solidFill>
+                  <a:srgbClr val="B6C3D7"/>
+                </a:solidFill>
+                <a:latin typeface="Aptos"/>
+              </a:defRPr>
+            </a:pPr>
+            <a:r>
+              <a:t>Fixes for the next freeze: Hinglish vocabulary, response-side and placeholder checks, measured relevance ranking. Details: results/ojaswi/misses-analysis.md</a:t>
+            </a:r>
+          </a:p>
+        </p:txBody>
+      </p:sp>
+    </p:spTree>
+  </p:cSld>
+  <p:clrMapOvr>
+    <a:masterClrMapping/>
+  </p:clrMapOvr>
+</p:sld>
+</file>
+
 <file path=ppt/slides/slide2.xml><?xml version="1.0" encoding="utf-8"?>
 <p:sld xmlns:a="http://schemas.openxmlformats.org/drawingml/2006/main" xmlns:p="http://schemas.openxmlformats.org/presentationml/2006/main" xmlns:r="http://schemas.openxmlformats.org/officeDocument/2006/relationships">
   <p:cSld>
@@ -6083,7 +6754,7 @@
               </a:defRPr>
             </a:pPr>
             <a:r>
-              <a:t>Classifier feasibility</a:t>
+              <a:t>Classifier: tested, kept off</a:t>
             </a:r>
           </a:p>
         </p:txBody>
@@ -6161,7 +6832,7 @@
               </a:defRPr>
             </a:pPr>
             <a:r>
-              <a:t>6</a:t>
+              <a:t>8</a:t>
             </a:r>
           </a:p>
         </p:txBody>
@@ -6176,7 +6847,7 @@
         </p:nvGraphicFramePr>
         <p:xfrm>
           <a:off x="640080" y="2011680"/>
-          <a:ext cx="10881360" cy="1783080"/>
+          <a:ext cx="10881360" cy="1828800"/>
         </p:xfrm>
         <a:graphic>
           <a:graphicData uri="http://schemas.openxmlformats.org/drawingml/2006/table">
@@ -6185,18 +6856,18 @@
                 <a:tableStyleId>{5C22544A-7EE6-4342-B048-85BDC9FD1C3A}</a:tableStyleId>
               </a:tblPr>
               <a:tblGrid>
-                <a:gridCol w="3627120"/>
-                <a:gridCol w="3627120"/>
-                <a:gridCol w="3627120"/>
+                <a:gridCol w="3657600"/>
+                <a:gridCol w="2560320"/>
+                <a:gridCol w="4663440"/>
               </a:tblGrid>
-              <a:tr h="594360">
+              <a:tr h="457200">
                 <a:tc>
                   <a:txBody>
                     <a:bodyPr/>
                     <a:lstStyle/>
                     <a:p>
                       <a:pPr>
-                        <a:defRPr sz="1900" b="1">
+                        <a:defRPr sz="1600" b="1">
                           <a:solidFill>
                             <a:srgbClr val="64DEB1"/>
                           </a:solidFill>
@@ -6204,7 +6875,13 @@
                         </a:defRPr>
                       </a:pPr>
                       <a:r>
-                        <a:t>Variant</a:t>
+                        <a:rPr lang="en-IN" sz="1600" b="1">
+                          <a:solidFill>
+                            <a:srgbClr val="64DEB1"/>
+                          </a:solidFill>
+                          <a:latin typeface="Aptos"/>
+                        </a:rPr>
+                        <a:t>Check</a:t>
                       </a:r>
                     </a:p>
                   </a:txBody>
@@ -6220,7 +6897,7 @@
                     <a:lstStyle/>
                     <a:p>
                       <a:pPr>
-                        <a:defRPr sz="1900" b="1">
+                        <a:defRPr sz="1600" b="1">
                           <a:solidFill>
                             <a:srgbClr val="64DEB1"/>
                           </a:solidFill>
@@ -6228,7 +6905,13 @@
                         </a:defRPr>
                       </a:pPr>
                       <a:r>
-                        <a:t>Warm p50</a:t>
+                        <a:rPr lang="en-IN" sz="1600" b="1">
+                          <a:solidFill>
+                            <a:srgbClr val="64DEB1"/>
+                          </a:solidFill>
+                          <a:latin typeface="Aptos"/>
+                        </a:rPr>
+                        <a:t>Speed</a:t>
                       </a:r>
                     </a:p>
                   </a:txBody>
@@ -6244,7 +6927,7 @@
                     <a:lstStyle/>
                     <a:p>
                       <a:pPr>
-                        <a:defRPr sz="1900" b="1">
+                        <a:defRPr sz="1600" b="1">
                           <a:solidFill>
                             <a:srgbClr val="64DEB1"/>
                           </a:solidFill>
@@ -6252,7 +6935,13 @@
                         </a:defRPr>
                       </a:pPr>
                       <a:r>
-                        <a:t>Warm p95</a:t>
+                        <a:rPr lang="en-IN" sz="1600" b="1">
+                          <a:solidFill>
+                            <a:srgbClr val="64DEB1"/>
+                          </a:solidFill>
+                          <a:latin typeface="Aptos"/>
+                        </a:rPr>
+                        <a:t>Result</a:t>
                       </a:r>
                     </a:p>
                   </a:txBody>
@@ -6263,14 +6952,14 @@
                   </a:tcPr>
                 </a:tc>
               </a:tr>
-              <a:tr h="594360">
+              <a:tr h="457200">
                 <a:tc>
                   <a:txBody>
                     <a:bodyPr/>
                     <a:lstStyle/>
                     <a:p>
                       <a:pPr>
-                        <a:defRPr sz="1900" b="0">
+                        <a:defRPr sz="1600" b="0">
                           <a:solidFill>
                             <a:srgbClr val="F1F5FA"/>
                           </a:solidFill>
@@ -6278,7 +6967,13 @@
                         </a:defRPr>
                       </a:pPr>
                       <a:r>
-                        <a:t>fp32</a:t>
+                        <a:rPr lang="en-IN" sz="1600" b="0">
+                          <a:solidFill>
+                            <a:srgbClr val="F1F5FA"/>
+                          </a:solidFill>
+                          <a:latin typeface="Aptos"/>
+                        </a:rPr>
+                        <a:t>fp32 spike, 6 prompts</a:t>
                       </a:r>
                     </a:p>
                   </a:txBody>
@@ -6294,7 +6989,7 @@
                     <a:lstStyle/>
                     <a:p>
                       <a:pPr>
-                        <a:defRPr sz="1900" b="0">
+                        <a:defRPr sz="1600" b="0">
                           <a:solidFill>
                             <a:srgbClr val="F1F5FA"/>
                           </a:solidFill>
@@ -6302,7 +6997,13 @@
                         </a:defRPr>
                       </a:pPr>
                       <a:r>
-                        <a:t>10.44 ms</a:t>
+                        <a:rPr lang="en-IN" sz="1600" b="0">
+                          <a:solidFill>
+                            <a:srgbClr val="F1F5FA"/>
+                          </a:solidFill>
+                          <a:latin typeface="Aptos"/>
+                        </a:rPr>
+                        <a:t>10.44 / 11.97 ms</a:t>
                       </a:r>
                     </a:p>
                   </a:txBody>
@@ -6318,7 +7019,7 @@
                     <a:lstStyle/>
                     <a:p>
                       <a:pPr>
-                        <a:defRPr sz="1900" b="0">
+                        <a:defRPr sz="1600" b="0">
                           <a:solidFill>
                             <a:srgbClr val="F1F5FA"/>
                           </a:solidFill>
@@ -6326,7 +7027,13 @@
                         </a:defRPr>
                       </a:pPr>
                       <a:r>
-                        <a:t>11.97 ms</a:t>
+                        <a:rPr lang="en-IN" sz="1600" b="0">
+                          <a:solidFill>
+                            <a:srgbClr val="F1F5FA"/>
+                          </a:solidFill>
+                          <a:latin typeface="Aptos"/>
+                        </a:rPr>
+                        <a:t>Node ONNX works</a:t>
                       </a:r>
                     </a:p>
                   </a:txBody>
@@ -6337,14 +7044,14 @@
                   </a:tcPr>
                 </a:tc>
               </a:tr>
-              <a:tr h="594360">
+              <a:tr h="457200">
                 <a:tc>
                   <a:txBody>
                     <a:bodyPr/>
                     <a:lstStyle/>
                     <a:p>
                       <a:pPr>
-                        <a:defRPr sz="1900" b="0">
+                        <a:defRPr sz="1600" b="0">
                           <a:solidFill>
                             <a:srgbClr val="F1F5FA"/>
                           </a:solidFill>
@@ -6352,7 +7059,13 @@
                         </a:defRPr>
                       </a:pPr>
                       <a:r>
-                        <a:t>q8</a:t>
+                        <a:rPr lang="en-IN" sz="1600" b="0">
+                          <a:solidFill>
+                            <a:srgbClr val="F1F5FA"/>
+                          </a:solidFill>
+                          <a:latin typeface="Aptos"/>
+                        </a:rPr>
+                        <a:t>fp32 real check, 110 normal + attacks</a:t>
                       </a:r>
                     </a:p>
                   </a:txBody>
@@ -6368,7 +7081,7 @@
                     <a:lstStyle/>
                     <a:p>
                       <a:pPr>
-                        <a:defRPr sz="1900" b="0">
+                        <a:defRPr sz="1600" b="0">
                           <a:solidFill>
                             <a:srgbClr val="F1F5FA"/>
                           </a:solidFill>
@@ -6376,7 +7089,13 @@
                         </a:defRPr>
                       </a:pPr>
                       <a:r>
-                        <a:t>6.35 ms</a:t>
+                        <a:rPr lang="en-IN" sz="1600" b="0">
+                          <a:solidFill>
+                            <a:srgbClr val="F1F5FA"/>
+                          </a:solidFill>
+                          <a:latin typeface="Aptos"/>
+                        </a:rPr>
+                        <a:t>~34 ms per prompt</a:t>
                       </a:r>
                     </a:p>
                   </a:txBody>
@@ -6392,7 +7111,7 @@
                     <a:lstStyle/>
                     <a:p>
                       <a:pPr>
-                        <a:defRPr sz="1900" b="0">
+                        <a:defRPr sz="1600" b="0">
                           <a:solidFill>
                             <a:srgbClr val="F1F5FA"/>
                           </a:solidFill>
@@ -6400,7 +7119,105 @@
                         </a:defRPr>
                       </a:pPr>
                       <a:r>
-                        <a:t>7.96 ms</a:t>
+                        <a:rPr lang="en-IN" sz="1600" b="0">
+                          <a:solidFill>
+                            <a:srgbClr val="F1F5FA"/>
+                          </a:solidFill>
+                          <a:latin typeface="Aptos"/>
+                        </a:rPr>
+                        <a:t>Caught 5/5 paraphrases; flagged 19/110 normal</a:t>
+                      </a:r>
+                    </a:p>
+                  </a:txBody>
+                  <a:tcPr>
+                    <a:solidFill>
+                      <a:srgbClr val="111B2B"/>
+                    </a:solidFill>
+                  </a:tcPr>
+                </a:tc>
+              </a:tr>
+              <a:tr h="457200">
+                <a:tc>
+                  <a:txBody>
+                    <a:bodyPr/>
+                    <a:lstStyle/>
+                    <a:p>
+                      <a:pPr>
+                        <a:defRPr sz="1600" b="0">
+                          <a:solidFill>
+                            <a:srgbClr val="F1F5FA"/>
+                          </a:solidFill>
+                          <a:latin typeface="Aptos"/>
+                        </a:defRPr>
+                      </a:pPr>
+                      <a:r>
+                        <a:rPr lang="en-IN" sz="1600" b="0">
+                          <a:solidFill>
+                            <a:srgbClr val="F1F5FA"/>
+                          </a:solidFill>
+                          <a:latin typeface="Aptos"/>
+                        </a:rPr>
+                        <a:t>q8 local int8</a:t>
+                      </a:r>
+                    </a:p>
+                  </a:txBody>
+                  <a:tcPr>
+                    <a:solidFill>
+                      <a:srgbClr val="111B2B"/>
+                    </a:solidFill>
+                  </a:tcPr>
+                </a:tc>
+                <a:tc>
+                  <a:txBody>
+                    <a:bodyPr/>
+                    <a:lstStyle/>
+                    <a:p>
+                      <a:pPr>
+                        <a:defRPr sz="1600" b="0">
+                          <a:solidFill>
+                            <a:srgbClr val="F1F5FA"/>
+                          </a:solidFill>
+                          <a:latin typeface="Aptos"/>
+                        </a:defRPr>
+                      </a:pPr>
+                      <a:r>
+                        <a:rPr lang="en-IN" sz="1600" b="0">
+                          <a:solidFill>
+                            <a:srgbClr val="F1F5FA"/>
+                          </a:solidFill>
+                          <a:latin typeface="Aptos"/>
+                        </a:rPr>
+                        <a:t>6.35 / 7.96 ms</a:t>
+                      </a:r>
+                    </a:p>
+                  </a:txBody>
+                  <a:tcPr>
+                    <a:solidFill>
+                      <a:srgbClr val="111B2B"/>
+                    </a:solidFill>
+                  </a:tcPr>
+                </a:tc>
+                <a:tc>
+                  <a:txBody>
+                    <a:bodyPr/>
+                    <a:lstStyle/>
+                    <a:p>
+                      <a:pPr>
+                        <a:defRPr sz="1600" b="0">
+                          <a:solidFill>
+                            <a:srgbClr val="F1F5FA"/>
+                          </a:solidFill>
+                          <a:latin typeface="Aptos"/>
+                        </a:defRPr>
+                      </a:pPr>
+                      <a:r>
+                        <a:rPr lang="en-IN" sz="1600" b="0">
+                          <a:solidFill>
+                            <a:srgbClr val="F1F5FA"/>
+                          </a:solidFill>
+                          <a:latin typeface="Aptos"/>
+                        </a:rPr>
+                        <a:t>Labelled recorded attacks SAFE: refused</a:t>
                       </a:r>
                     </a:p>
                   </a:txBody>
@@ -6449,7 +7266,7 @@
               </a:defRPr>
             </a:pPr>
             <a:r>
-              <a:t>Node works. Full precision loads directly upstream; int8 was generated locally. A sidecar was unnecessary.</a:t>
+              <a:t>Scores did not separate attacks from normal work, so it is off by default. Rules now cover the attack families it caught.</a:t>
             </a:r>
           </a:p>
         </p:txBody>
@@ -6488,7 +7305,7 @@
               </a:defRPr>
             </a:pPr>
             <a:r>
-              <a:t>Six short development prompts, three rounds; first round excluded. No long-window or Hinglish accuracy claim.</a:t>
+              <a:t>results/ojaswi/classifier-check.md · docs/CLASSIFIER-GATEWAY.md · English only; no Hinglish accuracy claim.</a:t>
             </a:r>
           </a:p>
         </p:txBody>
@@ -6631,7 +7448,7 @@
               </a:defRPr>
             </a:pPr>
             <a:r>
-              <a:t>7</a:t>
+              <a:t>9</a:t>
             </a:r>
           </a:p>
         </p:txBody>
@@ -7011,7 +7828,7 @@
               </a:defRPr>
             </a:pPr>
             <a:r>
-              <a:t>Integration limits and next gates</a:t>
+              <a:t>Limits and next steps</a:t>
             </a:r>
           </a:p>
         </p:txBody>
@@ -7050,7 +7867,7 @@
               </a:defRPr>
             </a:pPr>
             <a:r>
-              <a:t>8</a:t>
+              <a:t>10</a:t>
             </a:r>
           </a:p>
         </p:txBody>
@@ -7089,7 +7906,7 @@
               </a:defRPr>
             </a:pPr>
             <a:r>
-              <a:t>Ready: merged gateway, actual detectors, ACLs, encrypted approval replay, audit and connected UI.</a:t>
+              <a:t>Ready: merged gateway, actual detectors, ACLs, encrypted approval replay, audit, connected UI and a frozen real-Groq evaluation: provider leaks 12 → 1.</a:t>
             </a:r>
           </a:p>
         </p:txBody>
@@ -7128,7 +7945,7 @@
               </a:defRPr>
             </a:pPr>
             <a:r>
-              <a:t>Remaining: team Groq settings, a real Groq/Ollama run, full frozen evaluation and real-model rehearsal.</a:t>
+              <a:t>Next freeze: Hinglish vocabulary and a Hinglish-tuned classifier, response-side and placeholder detector fixes, measured retrieval relevance.</a:t>
             </a:r>
           </a:p>
         </p:txBody>
@@ -7167,7 +7984,952 @@
               </a:defRPr>
             </a:pPr>
             <a:r>
-              <a:t>Approved content reaches Groq. Fingerprints catch copying, not paraphrases. Team Groq settings still need account verification.</a:t>
+              <a:t>Approved content reaches Groq. Fingerprints catch copying, not paraphrases. Organisation-level Groq data retention is for the account owner to confirm.</a:t>
+            </a:r>
+          </a:p>
+        </p:txBody>
+      </p:sp>
+    </p:spTree>
+  </p:cSld>
+  <p:clrMapOvr>
+    <a:masterClrMapping/>
+  </p:clrMapOvr>
+</p:sld>
+</file>
+
+<file path=ppt/slides/slide9.xml><?xml version="1.0" encoding="utf-8"?>
+<p:sld xmlns:a="http://schemas.openxmlformats.org/drawingml/2006/main" xmlns:p="http://schemas.openxmlformats.org/presentationml/2006/main" xmlns:r="http://schemas.openxmlformats.org/officeDocument/2006/relationships">
+  <p:cSld>
+    <p:bg>
+      <p:bgPr>
+        <a:solidFill>
+          <a:srgbClr val="111B2B"/>
+        </a:solidFill>
+        <a:effectLst/>
+      </p:bgPr>
+    </p:bg>
+    <p:spTree>
+      <p:nvGrpSpPr>
+        <p:cNvPr id="1" name=""/>
+        <p:cNvGrpSpPr/>
+        <p:nvPr/>
+      </p:nvGrpSpPr>
+      <p:grpSpPr/>
+      <p:sp>
+        <p:nvSpPr>
+          <p:cNvPr id="2" name="TextBox 1"/>
+          <p:cNvSpPr txBox="1"/>
+          <p:nvPr/>
+        </p:nvSpPr>
+        <p:spPr>
+          <a:xfrm>
+            <a:off x="594360" y="438912"/>
+            <a:ext cx="10972800" cy="914400"/>
+          </a:xfrm>
+          <a:prstGeom prst="rect">
+            <a:avLst/>
+          </a:prstGeom>
+          <a:noFill/>
+        </p:spPr>
+        <p:txBody>
+          <a:bodyPr wrap="square">
+            <a:spAutoFit/>
+          </a:bodyPr>
+          <a:lstStyle/>
+          <a:p>
+            <a:pPr>
+              <a:spcAft>
+                <a:spcPts val="1400"/>
+              </a:spcAft>
+              <a:defRPr sz="3600" b="1">
+                <a:solidFill>
+                  <a:srgbClr val="F1F5FA"/>
+                </a:solidFill>
+                <a:latin typeface="Aptos"/>
+              </a:defRPr>
+            </a:pPr>
+            <a:r>
+              <a:t>Frozen held-out results</a:t>
+            </a:r>
+          </a:p>
+        </p:txBody>
+      </p:sp>
+      <p:sp>
+        <p:nvSpPr>
+          <p:cNvPr id="3" name="TextBox 2"/>
+          <p:cNvSpPr txBox="1"/>
+          <p:nvPr/>
+        </p:nvSpPr>
+        <p:spPr>
+          <a:xfrm>
+            <a:off x="621792" y="1371600"/>
+            <a:ext cx="10972800" cy="640080"/>
+          </a:xfrm>
+          <a:prstGeom prst="rect">
+            <a:avLst/>
+          </a:prstGeom>
+          <a:noFill/>
+        </p:spPr>
+        <p:txBody>
+          <a:bodyPr wrap="square">
+            <a:spAutoFit/>
+          </a:bodyPr>
+          <a:lstStyle/>
+          <a:p>
+            <a:pPr>
+              <a:spcAft>
+                <a:spcPts val="1400"/>
+              </a:spcAft>
+              <a:defRPr sz="1900" b="0">
+                <a:solidFill>
+                  <a:srgbClr val="B6C3D7"/>
+                </a:solidFill>
+                <a:latin typeface="Aptos"/>
+              </a:defRPr>
+            </a:pPr>
+            <a:r>
+              <a:t>Tag eval-freeze · real Groq openai/gpt-oss-20b · the same 60 cases with and without the gateway</a:t>
+            </a:r>
+          </a:p>
+        </p:txBody>
+      </p:sp>
+      <p:sp>
+        <p:nvSpPr>
+          <p:cNvPr id="4" name="TextBox 3"/>
+          <p:cNvSpPr txBox="1"/>
+          <p:nvPr/>
+        </p:nvSpPr>
+        <p:spPr>
+          <a:xfrm>
+            <a:off x="11064240" y="6355080"/>
+            <a:ext cx="457200" cy="274320"/>
+          </a:xfrm>
+          <a:prstGeom prst="rect">
+            <a:avLst/>
+          </a:prstGeom>
+          <a:noFill/>
+        </p:spPr>
+        <p:txBody>
+          <a:bodyPr wrap="square">
+            <a:spAutoFit/>
+          </a:bodyPr>
+          <a:lstStyle/>
+          <a:p>
+            <a:pPr>
+              <a:spcAft>
+                <a:spcPts val="1400"/>
+              </a:spcAft>
+              <a:defRPr sz="1200" b="0">
+                <a:solidFill>
+                  <a:srgbClr val="B6C3D7"/>
+                </a:solidFill>
+                <a:latin typeface="Aptos"/>
+              </a:defRPr>
+            </a:pPr>
+            <a:r>
+              <a:t>6</a:t>
+            </a:r>
+          </a:p>
+        </p:txBody>
+      </p:sp>
+      <p:graphicFrame>
+        <p:nvGraphicFramePr>
+          <p:cNvPr id="5" name="Table 4"/>
+          <p:cNvGraphicFramePr>
+            <a:graphicFrameLocks noGrp="1"/>
+          </p:cNvGraphicFramePr>
+          <p:nvPr/>
+        </p:nvGraphicFramePr>
+        <p:xfrm>
+          <a:off x="640080" y="1828800"/>
+          <a:ext cx="10881360" cy="3657600"/>
+        </p:xfrm>
+        <a:graphic>
+          <a:graphicData uri="http://schemas.openxmlformats.org/drawingml/2006/table">
+            <a:tbl>
+              <a:tblPr firstRow="1" bandRow="1">
+                <a:tableStyleId>{5C22544A-7EE6-4342-B048-85BDC9FD1C3A}</a:tableStyleId>
+              </a:tblPr>
+              <a:tblGrid>
+                <a:gridCol w="5440680"/>
+                <a:gridCol w="2720340"/>
+                <a:gridCol w="2720340"/>
+              </a:tblGrid>
+              <a:tr h="457200">
+                <a:tc>
+                  <a:txBody>
+                    <a:bodyPr/>
+                    <a:lstStyle/>
+                    <a:p>
+                      <a:pPr>
+                        <a:defRPr sz="1600" b="1">
+                          <a:solidFill>
+                            <a:srgbClr val="64DEB1"/>
+                          </a:solidFill>
+                          <a:latin typeface="Aptos"/>
+                        </a:defRPr>
+                      </a:pPr>
+                      <a:r>
+                        <a:rPr lang="en-IN" sz="1600" b="1">
+                          <a:solidFill>
+                            <a:srgbClr val="64DEB1"/>
+                          </a:solidFill>
+                          <a:latin typeface="Aptos"/>
+                        </a:rPr>
+                        <a:t>Measurement</a:t>
+                      </a:r>
+                    </a:p>
+                  </a:txBody>
+                  <a:tcPr>
+                    <a:solidFill>
+                      <a:srgbClr val="243449"/>
+                    </a:solidFill>
+                  </a:tcPr>
+                </a:tc>
+                <a:tc>
+                  <a:txBody>
+                    <a:bodyPr/>
+                    <a:lstStyle/>
+                    <a:p>
+                      <a:pPr>
+                        <a:defRPr sz="1600" b="1">
+                          <a:solidFill>
+                            <a:srgbClr val="64DEB1"/>
+                          </a:solidFill>
+                          <a:latin typeface="Aptos"/>
+                        </a:defRPr>
+                      </a:pPr>
+                      <a:r>
+                        <a:rPr lang="en-IN" sz="1600" b="1">
+                          <a:solidFill>
+                            <a:srgbClr val="64DEB1"/>
+                          </a:solidFill>
+                          <a:latin typeface="Aptos"/>
+                        </a:rPr>
+                        <a:t>LeakShield</a:t>
+                      </a:r>
+                    </a:p>
+                  </a:txBody>
+                  <a:tcPr>
+                    <a:solidFill>
+                      <a:srgbClr val="243449"/>
+                    </a:solidFill>
+                  </a:tcPr>
+                </a:tc>
+                <a:tc>
+                  <a:txBody>
+                    <a:bodyPr/>
+                    <a:lstStyle/>
+                    <a:p>
+                      <a:pPr>
+                        <a:defRPr sz="1600" b="1">
+                          <a:solidFill>
+                            <a:srgbClr val="64DEB1"/>
+                          </a:solidFill>
+                          <a:latin typeface="Aptos"/>
+                        </a:defRPr>
+                      </a:pPr>
+                      <a:r>
+                        <a:rPr lang="en-IN" sz="1600" b="1">
+                          <a:solidFill>
+                            <a:srgbClr val="64DEB1"/>
+                          </a:solidFill>
+                          <a:latin typeface="Aptos"/>
+                        </a:rPr>
+                        <a:t>No gateway</a:t>
+                      </a:r>
+                    </a:p>
+                  </a:txBody>
+                  <a:tcPr>
+                    <a:solidFill>
+                      <a:srgbClr val="243449"/>
+                    </a:solidFill>
+                  </a:tcPr>
+                </a:tc>
+              </a:tr>
+              <a:tr h="457200">
+                <a:tc>
+                  <a:txBody>
+                    <a:bodyPr/>
+                    <a:lstStyle/>
+                    <a:p>
+                      <a:pPr>
+                        <a:defRPr sz="1600" b="0">
+                          <a:solidFill>
+                            <a:srgbClr val="F1F5FA"/>
+                          </a:solidFill>
+                          <a:latin typeface="Aptos"/>
+                        </a:defRPr>
+                      </a:pPr>
+                      <a:r>
+                        <a:rPr lang="en-IN" sz="1600" b="0">
+                          <a:solidFill>
+                            <a:srgbClr val="F1F5FA"/>
+                          </a:solidFill>
+                          <a:latin typeface="Aptos"/>
+                        </a:rPr>
+                        <a:t>Provider-leak flags</a:t>
+                      </a:r>
+                    </a:p>
+                  </a:txBody>
+                  <a:tcPr>
+                    <a:solidFill>
+                      <a:srgbClr val="111B2B"/>
+                    </a:solidFill>
+                  </a:tcPr>
+                </a:tc>
+                <a:tc>
+                  <a:txBody>
+                    <a:bodyPr/>
+                    <a:lstStyle/>
+                    <a:p>
+                      <a:pPr>
+                        <a:defRPr sz="1600" b="0">
+                          <a:solidFill>
+                            <a:srgbClr val="F1F5FA"/>
+                          </a:solidFill>
+                          <a:latin typeface="Aptos"/>
+                        </a:defRPr>
+                      </a:pPr>
+                      <a:r>
+                        <a:rPr lang="en-IN" sz="1600" b="0">
+                          <a:solidFill>
+                            <a:srgbClr val="F1F5FA"/>
+                          </a:solidFill>
+                          <a:latin typeface="Aptos"/>
+                        </a:rPr>
+                        <a:t>1</a:t>
+                      </a:r>
+                    </a:p>
+                  </a:txBody>
+                  <a:tcPr>
+                    <a:solidFill>
+                      <a:srgbClr val="111B2B"/>
+                    </a:solidFill>
+                  </a:tcPr>
+                </a:tc>
+                <a:tc>
+                  <a:txBody>
+                    <a:bodyPr/>
+                    <a:lstStyle/>
+                    <a:p>
+                      <a:pPr>
+                        <a:defRPr sz="1600" b="0">
+                          <a:solidFill>
+                            <a:srgbClr val="F1F5FA"/>
+                          </a:solidFill>
+                          <a:latin typeface="Aptos"/>
+                        </a:defRPr>
+                      </a:pPr>
+                      <a:r>
+                        <a:rPr lang="en-IN" sz="1600" b="0">
+                          <a:solidFill>
+                            <a:srgbClr val="F1F5FA"/>
+                          </a:solidFill>
+                          <a:latin typeface="Aptos"/>
+                        </a:rPr>
+                        <a:t>12</a:t>
+                      </a:r>
+                    </a:p>
+                  </a:txBody>
+                  <a:tcPr>
+                    <a:solidFill>
+                      <a:srgbClr val="111B2B"/>
+                    </a:solidFill>
+                  </a:tcPr>
+                </a:tc>
+              </a:tr>
+              <a:tr h="457200">
+                <a:tc>
+                  <a:txBody>
+                    <a:bodyPr/>
+                    <a:lstStyle/>
+                    <a:p>
+                      <a:pPr>
+                        <a:defRPr sz="1600" b="0">
+                          <a:solidFill>
+                            <a:srgbClr val="F1F5FA"/>
+                          </a:solidFill>
+                          <a:latin typeface="Aptos"/>
+                        </a:defRPr>
+                      </a:pPr>
+                      <a:r>
+                        <a:rPr lang="en-IN" sz="1600" b="0">
+                          <a:solidFill>
+                            <a:srgbClr val="F1F5FA"/>
+                          </a:solidFill>
+                          <a:latin typeface="Aptos"/>
+                        </a:rPr>
+                        <a:t>User-leak flags</a:t>
+                      </a:r>
+                    </a:p>
+                  </a:txBody>
+                  <a:tcPr>
+                    <a:solidFill>
+                      <a:srgbClr val="111B2B"/>
+                    </a:solidFill>
+                  </a:tcPr>
+                </a:tc>
+                <a:tc>
+                  <a:txBody>
+                    <a:bodyPr/>
+                    <a:lstStyle/>
+                    <a:p>
+                      <a:pPr>
+                        <a:defRPr sz="1600" b="0">
+                          <a:solidFill>
+                            <a:srgbClr val="F1F5FA"/>
+                          </a:solidFill>
+                          <a:latin typeface="Aptos"/>
+                        </a:defRPr>
+                      </a:pPr>
+                      <a:r>
+                        <a:rPr lang="en-IN" sz="1600" b="0">
+                          <a:solidFill>
+                            <a:srgbClr val="F1F5FA"/>
+                          </a:solidFill>
+                          <a:latin typeface="Aptos"/>
+                        </a:rPr>
+                        <a:t>0</a:t>
+                      </a:r>
+                    </a:p>
+                  </a:txBody>
+                  <a:tcPr>
+                    <a:solidFill>
+                      <a:srgbClr val="111B2B"/>
+                    </a:solidFill>
+                  </a:tcPr>
+                </a:tc>
+                <a:tc>
+                  <a:txBody>
+                    <a:bodyPr/>
+                    <a:lstStyle/>
+                    <a:p>
+                      <a:pPr>
+                        <a:defRPr sz="1600" b="0">
+                          <a:solidFill>
+                            <a:srgbClr val="F1F5FA"/>
+                          </a:solidFill>
+                          <a:latin typeface="Aptos"/>
+                        </a:defRPr>
+                      </a:pPr>
+                      <a:r>
+                        <a:rPr lang="en-IN" sz="1600" b="0">
+                          <a:solidFill>
+                            <a:srgbClr val="F1F5FA"/>
+                          </a:solidFill>
+                          <a:latin typeface="Aptos"/>
+                        </a:rPr>
+                        <a:t>1</a:t>
+                      </a:r>
+                    </a:p>
+                  </a:txBody>
+                  <a:tcPr>
+                    <a:solidFill>
+                      <a:srgbClr val="111B2B"/>
+                    </a:solidFill>
+                  </a:tcPr>
+                </a:tc>
+              </a:tr>
+              <a:tr h="457200">
+                <a:tc>
+                  <a:txBody>
+                    <a:bodyPr/>
+                    <a:lstStyle/>
+                    <a:p>
+                      <a:pPr>
+                        <a:defRPr sz="1600" b="0">
+                          <a:solidFill>
+                            <a:srgbClr val="F1F5FA"/>
+                          </a:solidFill>
+                          <a:latin typeface="Aptos"/>
+                        </a:defRPr>
+                      </a:pPr>
+                      <a:r>
+                        <a:rPr lang="en-IN" sz="1600" b="0">
+                          <a:solidFill>
+                            <a:srgbClr val="F1F5FA"/>
+                          </a:solidFill>
+                          <a:latin typeface="Aptos"/>
+                        </a:rPr>
+                        <a:t>Exact expected action</a:t>
+                      </a:r>
+                    </a:p>
+                  </a:txBody>
+                  <a:tcPr>
+                    <a:solidFill>
+                      <a:srgbClr val="111B2B"/>
+                    </a:solidFill>
+                  </a:tcPr>
+                </a:tc>
+                <a:tc>
+                  <a:txBody>
+                    <a:bodyPr/>
+                    <a:lstStyle/>
+                    <a:p>
+                      <a:pPr>
+                        <a:defRPr sz="1600" b="0">
+                          <a:solidFill>
+                            <a:srgbClr val="F1F5FA"/>
+                          </a:solidFill>
+                          <a:latin typeface="Aptos"/>
+                        </a:defRPr>
+                      </a:pPr>
+                      <a:r>
+                        <a:rPr lang="en-IN" sz="1600" b="0">
+                          <a:solidFill>
+                            <a:srgbClr val="F1F5FA"/>
+                          </a:solidFill>
+                          <a:latin typeface="Aptos"/>
+                        </a:rPr>
+                        <a:t>48 / 60</a:t>
+                      </a:r>
+                    </a:p>
+                  </a:txBody>
+                  <a:tcPr>
+                    <a:solidFill>
+                      <a:srgbClr val="111B2B"/>
+                    </a:solidFill>
+                  </a:tcPr>
+                </a:tc>
+                <a:tc>
+                  <a:txBody>
+                    <a:bodyPr/>
+                    <a:lstStyle/>
+                    <a:p>
+                      <a:pPr>
+                        <a:defRPr sz="1600" b="0">
+                          <a:solidFill>
+                            <a:srgbClr val="F1F5FA"/>
+                          </a:solidFill>
+                          <a:latin typeface="Aptos"/>
+                        </a:defRPr>
+                      </a:pPr>
+                      <a:r>
+                        <a:rPr lang="en-IN" sz="1600" b="0">
+                          <a:solidFill>
+                            <a:srgbClr val="F1F5FA"/>
+                          </a:solidFill>
+                          <a:latin typeface="Aptos"/>
+                        </a:rPr>
+                        <a:t>26 / 60</a:t>
+                      </a:r>
+                    </a:p>
+                  </a:txBody>
+                  <a:tcPr>
+                    <a:solidFill>
+                      <a:srgbClr val="111B2B"/>
+                    </a:solidFill>
+                  </a:tcPr>
+                </a:tc>
+              </a:tr>
+              <a:tr h="457200">
+                <a:tc>
+                  <a:txBody>
+                    <a:bodyPr/>
+                    <a:lstStyle/>
+                    <a:p>
+                      <a:pPr>
+                        <a:defRPr sz="1600" b="0">
+                          <a:solidFill>
+                            <a:srgbClr val="F1F5FA"/>
+                          </a:solidFill>
+                          <a:latin typeface="Aptos"/>
+                        </a:defRPr>
+                      </a:pPr>
+                      <a:r>
+                        <a:rPr lang="en-IN" sz="1600" b="0">
+                          <a:solidFill>
+                            <a:srgbClr val="F1F5FA"/>
+                          </a:solidFill>
+                          <a:latin typeface="Aptos"/>
+                        </a:rPr>
+                        <a:t>Intervention recall / precision</a:t>
+                      </a:r>
+                    </a:p>
+                  </a:txBody>
+                  <a:tcPr>
+                    <a:solidFill>
+                      <a:srgbClr val="111B2B"/>
+                    </a:solidFill>
+                  </a:tcPr>
+                </a:tc>
+                <a:tc>
+                  <a:txBody>
+                    <a:bodyPr/>
+                    <a:lstStyle/>
+                    <a:p>
+                      <a:pPr>
+                        <a:defRPr sz="1600" b="0">
+                          <a:solidFill>
+                            <a:srgbClr val="F1F5FA"/>
+                          </a:solidFill>
+                          <a:latin typeface="Aptos"/>
+                        </a:defRPr>
+                      </a:pPr>
+                      <a:r>
+                        <a:rPr lang="en-IN" sz="1600" b="0">
+                          <a:solidFill>
+                            <a:srgbClr val="F1F5FA"/>
+                          </a:solidFill>
+                          <a:latin typeface="Aptos"/>
+                        </a:rPr>
+                        <a:t>1.00 / 0.82</a:t>
+                      </a:r>
+                    </a:p>
+                  </a:txBody>
+                  <a:tcPr>
+                    <a:solidFill>
+                      <a:srgbClr val="111B2B"/>
+                    </a:solidFill>
+                  </a:tcPr>
+                </a:tc>
+                <a:tc>
+                  <a:txBody>
+                    <a:bodyPr/>
+                    <a:lstStyle/>
+                    <a:p>
+                      <a:pPr>
+                        <a:defRPr sz="1600" b="0">
+                          <a:solidFill>
+                            <a:srgbClr val="F1F5FA"/>
+                          </a:solidFill>
+                          <a:latin typeface="Aptos"/>
+                        </a:defRPr>
+                      </a:pPr>
+                      <a:r>
+                        <a:rPr lang="en-IN" sz="1600" b="0">
+                          <a:solidFill>
+                            <a:srgbClr val="F1F5FA"/>
+                          </a:solidFill>
+                          <a:latin typeface="Aptos"/>
+                        </a:rPr>
+                        <a:t>0 / –</a:t>
+                      </a:r>
+                    </a:p>
+                  </a:txBody>
+                  <a:tcPr>
+                    <a:solidFill>
+                      <a:srgbClr val="111B2B"/>
+                    </a:solidFill>
+                  </a:tcPr>
+                </a:tc>
+              </a:tr>
+              <a:tr h="457200">
+                <a:tc>
+                  <a:txBody>
+                    <a:bodyPr/>
+                    <a:lstStyle/>
+                    <a:p>
+                      <a:pPr>
+                        <a:defRPr sz="1600" b="0">
+                          <a:solidFill>
+                            <a:srgbClr val="F1F5FA"/>
+                          </a:solidFill>
+                          <a:latin typeface="Aptos"/>
+                        </a:defRPr>
+                      </a:pPr>
+                      <a:r>
+                        <a:rPr lang="en-IN" sz="1600" b="0">
+                          <a:solidFill>
+                            <a:srgbClr val="F1F5FA"/>
+                          </a:solidFill>
+                          <a:latin typeface="Aptos"/>
+                        </a:rPr>
+                        <a:t>Allowed work interrupted</a:t>
+                      </a:r>
+                    </a:p>
+                  </a:txBody>
+                  <a:tcPr>
+                    <a:solidFill>
+                      <a:srgbClr val="111B2B"/>
+                    </a:solidFill>
+                  </a:tcPr>
+                </a:tc>
+                <a:tc>
+                  <a:txBody>
+                    <a:bodyPr/>
+                    <a:lstStyle/>
+                    <a:p>
+                      <a:pPr>
+                        <a:defRPr sz="1600" b="0">
+                          <a:solidFill>
+                            <a:srgbClr val="F1F5FA"/>
+                          </a:solidFill>
+                          <a:latin typeface="Aptos"/>
+                        </a:defRPr>
+                      </a:pPr>
+                      <a:r>
+                        <a:rPr lang="en-IN" sz="1600" b="0">
+                          <a:solidFill>
+                            <a:srgbClr val="F1F5FA"/>
+                          </a:solidFill>
+                          <a:latin typeface="Aptos"/>
+                        </a:rPr>
+                        <a:t>7 / 28</a:t>
+                      </a:r>
+                    </a:p>
+                  </a:txBody>
+                  <a:tcPr>
+                    <a:solidFill>
+                      <a:srgbClr val="111B2B"/>
+                    </a:solidFill>
+                  </a:tcPr>
+                </a:tc>
+                <a:tc>
+                  <a:txBody>
+                    <a:bodyPr/>
+                    <a:lstStyle/>
+                    <a:p>
+                      <a:pPr>
+                        <a:defRPr sz="1600" b="0">
+                          <a:solidFill>
+                            <a:srgbClr val="F1F5FA"/>
+                          </a:solidFill>
+                          <a:latin typeface="Aptos"/>
+                        </a:defRPr>
+                      </a:pPr>
+                      <a:r>
+                        <a:rPr lang="en-IN" sz="1600" b="0">
+                          <a:solidFill>
+                            <a:srgbClr val="F1F5FA"/>
+                          </a:solidFill>
+                          <a:latin typeface="Aptos"/>
+                        </a:rPr>
+                        <a:t>0 / 28</a:t>
+                      </a:r>
+                    </a:p>
+                  </a:txBody>
+                  <a:tcPr>
+                    <a:solidFill>
+                      <a:srgbClr val="111B2B"/>
+                    </a:solidFill>
+                  </a:tcPr>
+                </a:tc>
+              </a:tr>
+              <a:tr h="457200">
+                <a:tc>
+                  <a:txBody>
+                    <a:bodyPr/>
+                    <a:lstStyle/>
+                    <a:p>
+                      <a:pPr>
+                        <a:defRPr sz="1600" b="0">
+                          <a:solidFill>
+                            <a:srgbClr val="F1F5FA"/>
+                          </a:solidFill>
+                          <a:latin typeface="Aptos"/>
+                        </a:defRPr>
+                      </a:pPr>
+                      <a:r>
+                        <a:rPr lang="en-IN" sz="1600" b="0">
+                          <a:solidFill>
+                            <a:srgbClr val="F1F5FA"/>
+                          </a:solidFill>
+                          <a:latin typeface="Aptos"/>
+                        </a:rPr>
+                        <a:t>Reworded attacks (60): leaks · retention</a:t>
+                      </a:r>
+                    </a:p>
+                  </a:txBody>
+                  <a:tcPr>
+                    <a:solidFill>
+                      <a:srgbClr val="111B2B"/>
+                    </a:solidFill>
+                  </a:tcPr>
+                </a:tc>
+                <a:tc>
+                  <a:txBody>
+                    <a:bodyPr/>
+                    <a:lstStyle/>
+                    <a:p>
+                      <a:pPr>
+                        <a:defRPr sz="1600" b="0">
+                          <a:solidFill>
+                            <a:srgbClr val="F1F5FA"/>
+                          </a:solidFill>
+                          <a:latin typeface="Aptos"/>
+                        </a:defRPr>
+                      </a:pPr>
+                      <a:r>
+                        <a:rPr lang="en-IN" sz="1600" b="0">
+                          <a:solidFill>
+                            <a:srgbClr val="F1F5FA"/>
+                          </a:solidFill>
+                          <a:latin typeface="Aptos"/>
+                        </a:rPr>
+                        <a:t>0 · 0.95</a:t>
+                      </a:r>
+                    </a:p>
+                  </a:txBody>
+                  <a:tcPr>
+                    <a:solidFill>
+                      <a:srgbClr val="111B2B"/>
+                    </a:solidFill>
+                  </a:tcPr>
+                </a:tc>
+                <a:tc>
+                  <a:txBody>
+                    <a:bodyPr/>
+                    <a:lstStyle/>
+                    <a:p>
+                      <a:pPr>
+                        <a:defRPr sz="1600" b="0">
+                          <a:solidFill>
+                            <a:srgbClr val="F1F5FA"/>
+                          </a:solidFill>
+                          <a:latin typeface="Aptos"/>
+                        </a:defRPr>
+                      </a:pPr>
+                      <a:r>
+                        <a:rPr lang="en-IN" sz="1600" b="0">
+                          <a:solidFill>
+                            <a:srgbClr val="F1F5FA"/>
+                          </a:solidFill>
+                          <a:latin typeface="Aptos"/>
+                        </a:rPr>
+                        <a:t>–</a:t>
+                      </a:r>
+                    </a:p>
+                  </a:txBody>
+                  <a:tcPr>
+                    <a:solidFill>
+                      <a:srgbClr val="111B2B"/>
+                    </a:solidFill>
+                  </a:tcPr>
+                </a:tc>
+              </a:tr>
+              <a:tr h="457200">
+                <a:tc>
+                  <a:txBody>
+                    <a:bodyPr/>
+                    <a:lstStyle/>
+                    <a:p>
+                      <a:pPr>
+                        <a:defRPr sz="1600" b="0">
+                          <a:solidFill>
+                            <a:srgbClr val="F1F5FA"/>
+                          </a:solidFill>
+                          <a:latin typeface="Aptos"/>
+                        </a:defRPr>
+                      </a:pPr>
+                      <a:r>
+                        <a:rPr lang="en-IN" sz="1600" b="0">
+                          <a:solidFill>
+                            <a:srgbClr val="F1F5FA"/>
+                          </a:solidFill>
+                          <a:latin typeface="Aptos"/>
+                        </a:rPr>
+                        <a:t>Gateway overhead p50 / p95 (no model time)</a:t>
+                      </a:r>
+                    </a:p>
+                  </a:txBody>
+                  <a:tcPr>
+                    <a:solidFill>
+                      <a:srgbClr val="111B2B"/>
+                    </a:solidFill>
+                  </a:tcPr>
+                </a:tc>
+                <a:tc>
+                  <a:txBody>
+                    <a:bodyPr/>
+                    <a:lstStyle/>
+                    <a:p>
+                      <a:pPr>
+                        <a:defRPr sz="1600" b="0">
+                          <a:solidFill>
+                            <a:srgbClr val="F1F5FA"/>
+                          </a:solidFill>
+                          <a:latin typeface="Aptos"/>
+                        </a:defRPr>
+                      </a:pPr>
+                      <a:r>
+                        <a:rPr lang="en-IN" sz="1600" b="0">
+                          <a:solidFill>
+                            <a:srgbClr val="F1F5FA"/>
+                          </a:solidFill>
+                          <a:latin typeface="Aptos"/>
+                        </a:rPr>
+                        <a:t>24 / 70 ms</a:t>
+                      </a:r>
+                    </a:p>
+                  </a:txBody>
+                  <a:tcPr>
+                    <a:solidFill>
+                      <a:srgbClr val="111B2B"/>
+                    </a:solidFill>
+                  </a:tcPr>
+                </a:tc>
+                <a:tc>
+                  <a:txBody>
+                    <a:bodyPr/>
+                    <a:lstStyle/>
+                    <a:p>
+                      <a:pPr>
+                        <a:defRPr sz="1600" b="0">
+                          <a:solidFill>
+                            <a:srgbClr val="F1F5FA"/>
+                          </a:solidFill>
+                          <a:latin typeface="Aptos"/>
+                        </a:defRPr>
+                      </a:pPr>
+                      <a:r>
+                        <a:rPr lang="en-IN" sz="1600" b="0">
+                          <a:solidFill>
+                            <a:srgbClr val="F1F5FA"/>
+                          </a:solidFill>
+                          <a:latin typeface="Aptos"/>
+                        </a:rPr>
+                        <a:t>–</a:t>
+                      </a:r>
+                    </a:p>
+                  </a:txBody>
+                  <a:tcPr>
+                    <a:solidFill>
+                      <a:srgbClr val="111B2B"/>
+                    </a:solidFill>
+                  </a:tcPr>
+                </a:tc>
+              </a:tr>
+            </a:tbl>
+          </a:graphicData>
+        </a:graphic>
+      </p:graphicFrame>
+      <p:sp>
+        <p:nvSpPr>
+          <p:cNvPr id="6" name="TextBox 5"/>
+          <p:cNvSpPr txBox="1"/>
+          <p:nvPr/>
+        </p:nvSpPr>
+        <p:spPr>
+          <a:xfrm>
+            <a:off x="685800" y="5669280"/>
+            <a:ext cx="10698480" cy="822960"/>
+          </a:xfrm>
+          <a:prstGeom prst="rect">
+            <a:avLst/>
+          </a:prstGeom>
+          <a:noFill/>
+        </p:spPr>
+        <p:txBody>
+          <a:bodyPr wrap="square">
+            <a:spAutoFit/>
+          </a:bodyPr>
+          <a:lstStyle/>
+          <a:p>
+            <a:pPr>
+              <a:spcAft>
+                <a:spcPts val="1400"/>
+              </a:spcAft>
+              <a:defRPr sz="1600" b="0">
+                <a:solidFill>
+                  <a:srgbClr val="B6C3D7"/>
+                </a:solidFill>
+                <a:latin typeface="Aptos"/>
+              </a:defRPr>
+            </a:pPr>
+            <a:r>
+              <a:t>91.7% fewer provider leaks. The one leak is an IFSC code that policy warns on by design. No rule changed after the run.</a:t>
             </a:r>
           </a:p>
         </p:txBody>

</xml_diff>